<commit_message>
Address Codex review: preserve per-slide Morph after set_transition
Both 03_product_launch and 10_marketing_campaign called
prs.set_transition(FADE) AFTER the introducing/big-idea helper
already set its slide to Morph. set_transition iterates every
slide and clobbered the per-slide override, so the Morph reveal
never made it to the saved deck.

Refactor _introducing and _big_idea to return their slide, then
apply the Morph override in build() AFTER the deck-wide fade.
Verified post-save: only the intended slide reads back as MORPH;
all others read as FADE.

https://claude.ai/code/session_012gX4Kv5LjTEL2qonW8KYgC
</commit_message>
<xml_diff>
--- a/examples/real_world/_out/03_product_launch.pptx
+++ b/examples/real_world/_out/03_product_launch.pptx
@@ -4918,8 +4918,8 @@
   <p:clrMapOvr>
     <a:masterClrMapping/>
   </p:clrMapOvr>
-  <p:transition xmlns:ns0="http://schemas.microsoft.com/office/powerpoint/2010/main" ns0:dur="400">
-    <p:fade/>
+  <p:transition xmlns:ns0="http://schemas.microsoft.com/office/powerpoint/2010/main" ns0:dur="1200">
+    <ns0:morph/>
   </p:transition>
   <p:timing>
     <p:tnLst>

</xml_diff>